<commit_message>
Encore plus de petits changements et ajout vidéo avec partie Arthur
</commit_message>
<xml_diff>
--- a/presentation_charte_CFF.pptx
+++ b/presentation_charte_CFF.pptx
@@ -7,6 +7,9 @@
   <p:notesMasterIdLst>
     <p:notesMasterId r:id="rId10"/>
   </p:notesMasterIdLst>
+  <p:handoutMasterIdLst>
+    <p:handoutMasterId r:id="rId11"/>
+  </p:handoutMasterIdLst>
   <p:sldIdLst>
     <p:sldId id="256" r:id="rId2"/>
     <p:sldId id="257" r:id="rId3"/>
@@ -18,7 +21,7 @@
     <p:sldId id="263" r:id="rId9"/>
   </p:sldIdLst>
   <p:sldSz cx="12192000" cy="6858000"/>
-  <p:notesSz cx="6858000" cy="12192000"/>
+  <p:notesSz cx="7104063" cy="10234613"/>
   <p:defaultTextStyle>
     <a:lvl1pPr marL="0" algn="l" defTabSz="914400" rtl="0">
       <a:defRPr sz="1800">
@@ -130,6 +133,199 @@
 </p:presentation>
 </file>
 
+<file path=ppt/handoutMasters/handoutMaster1.xml><?xml version="1.0" encoding="utf-8"?>
+<p:handoutMaster xmlns:a="http://schemas.openxmlformats.org/drawingml/2006/main" xmlns:r="http://schemas.openxmlformats.org/officeDocument/2006/relationships" xmlns:p="http://schemas.openxmlformats.org/presentationml/2006/main">
+  <p:cSld>
+    <p:bg>
+      <p:bgRef idx="1001">
+        <a:schemeClr val="bg1"/>
+      </p:bgRef>
+    </p:bg>
+    <p:spTree>
+      <p:nvGrpSpPr>
+        <p:cNvPr id="1" name=""/>
+        <p:cNvGrpSpPr/>
+        <p:nvPr/>
+      </p:nvGrpSpPr>
+      <p:grpSpPr>
+        <a:xfrm>
+          <a:off x="0" y="0"/>
+          <a:ext cx="0" cy="0"/>
+          <a:chOff x="0" y="0"/>
+          <a:chExt cx="0" cy="0"/>
+        </a:xfrm>
+      </p:grpSpPr>
+      <p:sp>
+        <p:nvSpPr>
+          <p:cNvPr id="2" name="Espace réservé de l'en-tête 1">
+            <a:extLst>
+              <a:ext uri="{FF2B5EF4-FFF2-40B4-BE49-F238E27FC236}">
+                <a16:creationId xmlns:a16="http://schemas.microsoft.com/office/drawing/2014/main" id="{811DD157-2DB1-3883-1274-262ED1BB0770}"/>
+              </a:ext>
+            </a:extLst>
+          </p:cNvPr>
+          <p:cNvSpPr>
+            <a:spLocks noGrp="1"/>
+          </p:cNvSpPr>
+          <p:nvPr>
+            <p:ph type="hdr" sz="quarter"/>
+          </p:nvPr>
+        </p:nvSpPr>
+        <p:spPr>
+          <a:xfrm>
+            <a:off x="0" y="0"/>
+            <a:ext cx="3078427" cy="513064"/>
+          </a:xfrm>
+          <a:prstGeom prst="rect">
+            <a:avLst/>
+          </a:prstGeom>
+        </p:spPr>
+        <p:txBody>
+          <a:bodyPr vert="horz" lIns="91440" tIns="45720" rIns="91440" bIns="45720" rtlCol="0"/>
+          <a:lstStyle>
+            <a:lvl1pPr algn="l">
+              <a:defRPr sz="1200"/>
+            </a:lvl1pPr>
+          </a:lstStyle>
+          <a:p>
+            <a:endParaRPr lang="fr-CH"/>
+          </a:p>
+        </p:txBody>
+      </p:sp>
+      <p:sp>
+        <p:nvSpPr>
+          <p:cNvPr id="3" name="Espace réservé de la date 2">
+            <a:extLst>
+              <a:ext uri="{FF2B5EF4-FFF2-40B4-BE49-F238E27FC236}">
+                <a16:creationId xmlns:a16="http://schemas.microsoft.com/office/drawing/2014/main" id="{F96E6F2A-CF79-8878-24E5-292771B597E1}"/>
+              </a:ext>
+            </a:extLst>
+          </p:cNvPr>
+          <p:cNvSpPr>
+            <a:spLocks noGrp="1"/>
+          </p:cNvSpPr>
+          <p:nvPr>
+            <p:ph type="dt" sz="quarter" idx="1"/>
+          </p:nvPr>
+        </p:nvSpPr>
+        <p:spPr>
+          <a:xfrm>
+            <a:off x="4023992" y="0"/>
+            <a:ext cx="3078427" cy="513064"/>
+          </a:xfrm>
+          <a:prstGeom prst="rect">
+            <a:avLst/>
+          </a:prstGeom>
+        </p:spPr>
+        <p:txBody>
+          <a:bodyPr vert="horz" lIns="91440" tIns="45720" rIns="91440" bIns="45720" rtlCol="0"/>
+          <a:lstStyle>
+            <a:lvl1pPr algn="r">
+              <a:defRPr sz="1200"/>
+            </a:lvl1pPr>
+          </a:lstStyle>
+          <a:p>
+            <a:fld id="{4658A873-F427-4A02-B61E-BE328D354BC7}" type="datetimeFigureOut">
+              <a:rPr lang="fr-CH" smtClean="0"/>
+              <a:t>05.06.2026</a:t>
+            </a:fld>
+            <a:endParaRPr lang="fr-CH"/>
+          </a:p>
+        </p:txBody>
+      </p:sp>
+      <p:sp>
+        <p:nvSpPr>
+          <p:cNvPr id="4" name="Espace réservé du pied de page 3">
+            <a:extLst>
+              <a:ext uri="{FF2B5EF4-FFF2-40B4-BE49-F238E27FC236}">
+                <a16:creationId xmlns:a16="http://schemas.microsoft.com/office/drawing/2014/main" id="{27815657-C857-8E09-5F7A-62E946EA590D}"/>
+              </a:ext>
+            </a:extLst>
+          </p:cNvPr>
+          <p:cNvSpPr>
+            <a:spLocks noGrp="1"/>
+          </p:cNvSpPr>
+          <p:nvPr>
+            <p:ph type="ftr" sz="quarter" idx="2"/>
+          </p:nvPr>
+        </p:nvSpPr>
+        <p:spPr>
+          <a:xfrm>
+            <a:off x="0" y="9721550"/>
+            <a:ext cx="3078427" cy="513063"/>
+          </a:xfrm>
+          <a:prstGeom prst="rect">
+            <a:avLst/>
+          </a:prstGeom>
+        </p:spPr>
+        <p:txBody>
+          <a:bodyPr vert="horz" lIns="91440" tIns="45720" rIns="91440" bIns="45720" rtlCol="0" anchor="b"/>
+          <a:lstStyle>
+            <a:lvl1pPr algn="l">
+              <a:defRPr sz="1200"/>
+            </a:lvl1pPr>
+          </a:lstStyle>
+          <a:p>
+            <a:r>
+              <a:rPr lang="fr-CH"/>
+              <a:t>https://www.rts.ch/info/suisse/2025/article/billets-de-train-trop-chers-l-erreur-qui-penalise-les-abonnes-regionaux-29052779.html</a:t>
+            </a:r>
+          </a:p>
+        </p:txBody>
+      </p:sp>
+      <p:sp>
+        <p:nvSpPr>
+          <p:cNvPr id="5" name="Espace réservé du numéro de diapositive 4">
+            <a:extLst>
+              <a:ext uri="{FF2B5EF4-FFF2-40B4-BE49-F238E27FC236}">
+                <a16:creationId xmlns:a16="http://schemas.microsoft.com/office/drawing/2014/main" id="{15CB52D6-694B-D536-58AA-4C4F9D70CB53}"/>
+              </a:ext>
+            </a:extLst>
+          </p:cNvPr>
+          <p:cNvSpPr>
+            <a:spLocks noGrp="1"/>
+          </p:cNvSpPr>
+          <p:nvPr>
+            <p:ph type="sldNum" sz="quarter" idx="3"/>
+          </p:nvPr>
+        </p:nvSpPr>
+        <p:spPr>
+          <a:xfrm>
+            <a:off x="4023992" y="9721550"/>
+            <a:ext cx="3078427" cy="513063"/>
+          </a:xfrm>
+          <a:prstGeom prst="rect">
+            <a:avLst/>
+          </a:prstGeom>
+        </p:spPr>
+        <p:txBody>
+          <a:bodyPr vert="horz" lIns="91440" tIns="45720" rIns="91440" bIns="45720" rtlCol="0" anchor="b"/>
+          <a:lstStyle>
+            <a:lvl1pPr algn="r">
+              <a:defRPr sz="1200"/>
+            </a:lvl1pPr>
+          </a:lstStyle>
+          <a:p>
+            <a:fld id="{172283BD-0A6C-47D8-9CF1-D58156F552D3}" type="slidenum">
+              <a:rPr lang="fr-CH" smtClean="0"/>
+              <a:t>‹N°›</a:t>
+            </a:fld>
+            <a:endParaRPr lang="fr-CH"/>
+          </a:p>
+        </p:txBody>
+      </p:sp>
+    </p:spTree>
+    <p:extLst>
+      <p:ext uri="{BB962C8B-B14F-4D97-AF65-F5344CB8AC3E}">
+        <p14:creationId xmlns:p14="http://schemas.microsoft.com/office/powerpoint/2010/main" val="4075614187"/>
+      </p:ext>
+    </p:extLst>
+  </p:cSld>
+  <p:clrMap bg1="lt1" tx1="dk1" bg2="lt2" tx2="dk2" accent1="accent1" accent2="accent2" accent3="accent3" accent4="accent4" accent5="accent5" accent6="accent6" hlink="hlink" folHlink="folHlink"/>
+  <p:hf hdr="0" ftr="0" dt="0"/>
+</p:handoutMaster>
+</file>
+
 <file path=ppt/notesMasters/notesMaster1.xml><?xml version="1.0" encoding="utf-8"?>
 <p:notesMaster xmlns:a="http://schemas.openxmlformats.org/drawingml/2006/main" xmlns:r="http://schemas.openxmlformats.org/officeDocument/2006/relationships" xmlns:p="http://schemas.openxmlformats.org/presentationml/2006/main">
   <p:cSld>
@@ -165,7 +361,7 @@
         <p:spPr bwMode="auto">
           <a:xfrm>
             <a:off x="0" y="0"/>
-            <a:ext cx="2971800" cy="458788"/>
+            <a:ext cx="3078427" cy="385131"/>
           </a:xfrm>
           <a:prstGeom prst="rect">
             <a:avLst/>
@@ -198,8 +394,8 @@
         </p:nvSpPr>
         <p:spPr bwMode="auto">
           <a:xfrm>
-            <a:off x="3884613" y="0"/>
-            <a:ext cx="2971800" cy="458788"/>
+            <a:off x="4023992" y="0"/>
+            <a:ext cx="3078427" cy="385131"/>
           </a:xfrm>
           <a:prstGeom prst="rect">
             <a:avLst/>
@@ -236,8 +432,8 @@
         </p:nvSpPr>
         <p:spPr bwMode="auto">
           <a:xfrm>
-            <a:off x="685800" y="1143000"/>
-            <a:ext cx="5486400" cy="3086100"/>
+            <a:off x="1249363" y="958850"/>
+            <a:ext cx="4606925" cy="2590800"/>
           </a:xfrm>
           <a:prstGeom prst="rect">
             <a:avLst/>
@@ -272,8 +468,8 @@
         </p:nvSpPr>
         <p:spPr bwMode="auto">
           <a:xfrm>
-            <a:off x="685800" y="4400550"/>
-            <a:ext cx="5486400" cy="3600450"/>
+            <a:off x="710407" y="3694056"/>
+            <a:ext cx="5683250" cy="3022409"/>
           </a:xfrm>
           <a:prstGeom prst="rect">
             <a:avLst/>
@@ -346,8 +542,8 @@
         </p:nvSpPr>
         <p:spPr bwMode="auto">
           <a:xfrm>
-            <a:off x="0" y="8685213"/>
-            <a:ext cx="2971800" cy="458787"/>
+            <a:off x="0" y="7290830"/>
+            <a:ext cx="3078427" cy="385130"/>
           </a:xfrm>
           <a:prstGeom prst="rect">
             <a:avLst/>
@@ -364,7 +560,10 @@
             <a:pPr>
               <a:defRPr/>
             </a:pPr>
-            <a:endParaRPr lang="en-US"/>
+            <a:r>
+              <a:rPr lang="en-US"/>
+              <a:t>https://www.rts.ch/info/suisse/2025/article/billets-de-train-trop-chers-l-erreur-qui-penalise-les-abonnes-regionaux-29052779.html</a:t>
+            </a:r>
           </a:p>
         </p:txBody>
       </p:sp>
@@ -380,8 +579,8 @@
         </p:nvSpPr>
         <p:spPr bwMode="auto">
           <a:xfrm>
-            <a:off x="3884613" y="8685213"/>
-            <a:ext cx="2971800" cy="458787"/>
+            <a:off x="4023992" y="7290830"/>
+            <a:ext cx="3078427" cy="385130"/>
           </a:xfrm>
           <a:prstGeom prst="rect">
             <a:avLst/>
@@ -409,6 +608,7 @@
     </p:spTree>
   </p:cSld>
   <p:clrMap bg1="lt1" tx1="dk1" bg2="lt2" tx2="dk2" accent1="accent1" accent2="accent2" accent3="accent3" accent4="accent4" accent5="accent5" accent6="accent6" hlink="hlink" folHlink="folHlink"/>
+  <p:hf hdr="0" ftr="0" dt="0"/>
   <p:notesStyle>
     <a:lvl1pPr marL="0" algn="l" defTabSz="914400" rtl="0">
       <a:defRPr sz="1200">
@@ -815,10 +1015,7 @@
             <a:pPr>
               <a:defRPr/>
             </a:pPr>
-            <a:r>
-              <a:rPr lang="en-US"/>
-              <a:t>Arthur : sur l'IA (prix EasyRide, fraude, prévision d'affluence), nous posons quatre garde-fous : transparence, contrôle humain pour toute décision à conséquences, audit des biais, et non-substitution du jugement humain. L'algorithme aide, mais ne tranche jamais seul une amende ou un blocage.</a:t>
-            </a:r>
+            <a:endParaRPr lang="en-US" dirty="0"/>
           </a:p>
         </p:txBody>
       </p:sp>
@@ -903,10 +1100,7 @@
             <a:pPr>
               <a:defRPr/>
             </a:pPr>
-            <a:r>
-              <a:rPr lang="en-US"/>
-              <a:t>Arthur : dans un service public, la confiance est essentielle. Nous minimisons les données, les hébergeons en Suisse, refusons toute revente publicitaire et tout historique permanent des trajets. Et nous refusons la biométrie obligatoire : on doit pouvoir se déplacer sans être identifié ni tracé.</a:t>
-            </a:r>
+            <a:endParaRPr lang="en-US" dirty="0"/>
           </a:p>
         </p:txBody>
       </p:sp>
@@ -1266,7 +1460,7 @@
   <p:sldLayoutIdLst>
     <p:sldLayoutId id="2147483649" r:id="rId1"/>
   </p:sldLayoutIdLst>
-  <p:hf sldNum="0" hdr="0" ftr="0" dt="0"/>
+  <p:hf sldNum="0" hdr="0" dt="0"/>
   <p:txStyles>
     <p:titleStyle>
       <a:lvl1pPr algn="ctr" defTabSz="914400" rtl="0">
@@ -3374,7 +3568,7 @@
               <a:defRPr/>
             </a:pPr>
             <a:r>
-              <a:rPr lang="en-US" sz="1650" b="1">
+              <a:rPr lang="en-US" sz="1650" b="1" dirty="0">
                 <a:solidFill>
                   <a:srgbClr val="1F2328"/>
                 </a:solidFill>
@@ -3385,6 +3579,116 @@
               <a:t>Transparence :</a:t>
             </a:r>
             <a:r>
+              <a:rPr lang="en-US" sz="1650" dirty="0">
+                <a:solidFill>
+                  <a:srgbClr val="5B6470"/>
+                </a:solidFill>
+                <a:latin typeface="Calibri"/>
+                <a:ea typeface="Calibri"/>
+                <a:cs typeface="Calibri"/>
+              </a:rPr>
+              <a:t>  savoir </a:t>
+            </a:r>
+            <a:r>
+              <a:rPr lang="en-US" sz="1650" dirty="0" err="1">
+                <a:solidFill>
+                  <a:srgbClr val="5B6470"/>
+                </a:solidFill>
+                <a:latin typeface="Calibri"/>
+                <a:ea typeface="Calibri"/>
+                <a:cs typeface="Calibri"/>
+              </a:rPr>
+              <a:t>quand</a:t>
+            </a:r>
+            <a:r>
+              <a:rPr lang="en-US" sz="1650" dirty="0">
+                <a:solidFill>
+                  <a:srgbClr val="5B6470"/>
+                </a:solidFill>
+                <a:latin typeface="Calibri"/>
+                <a:ea typeface="Calibri"/>
+                <a:cs typeface="Calibri"/>
+              </a:rPr>
+              <a:t> </a:t>
+            </a:r>
+            <a:r>
+              <a:rPr lang="en-US" sz="1650" dirty="0" err="1">
+                <a:solidFill>
+                  <a:srgbClr val="5B6470"/>
+                </a:solidFill>
+                <a:latin typeface="Calibri"/>
+                <a:ea typeface="Calibri"/>
+                <a:cs typeface="Calibri"/>
+              </a:rPr>
+              <a:t>une</a:t>
+            </a:r>
+            <a:r>
+              <a:rPr lang="en-US" sz="1650" dirty="0">
+                <a:solidFill>
+                  <a:srgbClr val="5B6470"/>
+                </a:solidFill>
+                <a:latin typeface="Calibri"/>
+                <a:ea typeface="Calibri"/>
+                <a:cs typeface="Calibri"/>
+              </a:rPr>
+              <a:t> </a:t>
+            </a:r>
+            <a:r>
+              <a:rPr lang="en-US" sz="1650" dirty="0" err="1">
+                <a:solidFill>
+                  <a:srgbClr val="5B6470"/>
+                </a:solidFill>
+                <a:latin typeface="Calibri"/>
+                <a:ea typeface="Calibri"/>
+                <a:cs typeface="Calibri"/>
+              </a:rPr>
+              <a:t>décision</a:t>
+            </a:r>
+            <a:r>
+              <a:rPr lang="en-US" sz="1650" dirty="0">
+                <a:solidFill>
+                  <a:srgbClr val="5B6470"/>
+                </a:solidFill>
+                <a:latin typeface="Calibri"/>
+                <a:ea typeface="Calibri"/>
+                <a:cs typeface="Calibri"/>
+              </a:rPr>
+              <a:t> est </a:t>
+            </a:r>
+            <a:r>
+              <a:rPr lang="en-US" sz="1650" dirty="0" err="1">
+                <a:solidFill>
+                  <a:srgbClr val="5B6470"/>
+                </a:solidFill>
+                <a:latin typeface="Calibri"/>
+                <a:ea typeface="Calibri"/>
+                <a:cs typeface="Calibri"/>
+              </a:rPr>
+              <a:t>automatisée</a:t>
+            </a:r>
+            <a:r>
+              <a:rPr lang="en-US" sz="1650" dirty="0">
+                <a:solidFill>
+                  <a:srgbClr val="5B6470"/>
+                </a:solidFill>
+                <a:latin typeface="Calibri"/>
+                <a:ea typeface="Calibri"/>
+                <a:cs typeface="Calibri"/>
+              </a:rPr>
+              <a:t> et comment un prix est </a:t>
+            </a:r>
+            <a:r>
+              <a:rPr lang="en-US" sz="1650" dirty="0" err="1">
+                <a:solidFill>
+                  <a:srgbClr val="5B6470"/>
+                </a:solidFill>
+                <a:latin typeface="Calibri"/>
+                <a:ea typeface="Calibri"/>
+                <a:cs typeface="Calibri"/>
+              </a:rPr>
+              <a:t>calculé</a:t>
+            </a:r>
+            <a:r>
               <a:rPr lang="en-US" sz="1650">
                 <a:solidFill>
                   <a:srgbClr val="5B6470"/>
@@ -3393,9 +3697,16 @@
                 <a:ea typeface="Calibri"/>
                 <a:cs typeface="Calibri"/>
               </a:rPr>
-              <a:t>  savoir quand une décision est automatisée et comment un prix est calculé.</a:t>
-            </a:r>
-            <a:endParaRPr lang="en-US" sz="1650"/>
+              <a:t>.</a:t>
+            </a:r>
+            <a:endParaRPr lang="en-US" sz="1650" baseline="30000" dirty="0">
+              <a:solidFill>
+                <a:srgbClr val="5B6470"/>
+              </a:solidFill>
+              <a:latin typeface="Calibri"/>
+              <a:ea typeface="Calibri"/>
+              <a:cs typeface="Calibri"/>
+            </a:endParaRPr>
           </a:p>
         </p:txBody>
       </p:sp>
@@ -3495,7 +3806,7 @@
               <a:defRPr/>
             </a:pPr>
             <a:r>
-              <a:rPr lang="en-US" sz="1650" b="1">
+              <a:rPr lang="en-US" sz="1650" b="1" dirty="0">
                 <a:solidFill>
                   <a:srgbClr val="1F2328"/>
                 </a:solidFill>
@@ -3506,7 +3817,7 @@
               <a:t>« Human in the loop » :</a:t>
             </a:r>
             <a:r>
-              <a:rPr lang="en-US" sz="1650">
+              <a:rPr lang="en-US" sz="1650" dirty="0">
                 <a:solidFill>
                   <a:srgbClr val="5B6470"/>
                 </a:solidFill>
@@ -3514,9 +3825,163 @@
                 <a:ea typeface="Calibri"/>
                 <a:cs typeface="Calibri"/>
               </a:rPr>
-              <a:t>  aucune décision lourde (amende, blocage) prise par l'algorithme seul.</a:t>
-            </a:r>
-            <a:endParaRPr lang="en-US" sz="1650"/>
+              <a:t>  </a:t>
+            </a:r>
+            <a:r>
+              <a:rPr lang="en-US" sz="1650" dirty="0" err="1">
+                <a:solidFill>
+                  <a:srgbClr val="5B6470"/>
+                </a:solidFill>
+                <a:latin typeface="Calibri"/>
+                <a:ea typeface="Calibri"/>
+                <a:cs typeface="Calibri"/>
+              </a:rPr>
+              <a:t>aucune</a:t>
+            </a:r>
+            <a:r>
+              <a:rPr lang="en-US" sz="1650" dirty="0">
+                <a:solidFill>
+                  <a:srgbClr val="5B6470"/>
+                </a:solidFill>
+                <a:latin typeface="Calibri"/>
+                <a:ea typeface="Calibri"/>
+                <a:cs typeface="Calibri"/>
+              </a:rPr>
+              <a:t> </a:t>
+            </a:r>
+            <a:r>
+              <a:rPr lang="en-US" sz="1650" dirty="0" err="1">
+                <a:solidFill>
+                  <a:srgbClr val="5B6470"/>
+                </a:solidFill>
+                <a:latin typeface="Calibri"/>
+                <a:ea typeface="Calibri"/>
+                <a:cs typeface="Calibri"/>
+              </a:rPr>
+              <a:t>décision</a:t>
+            </a:r>
+            <a:r>
+              <a:rPr lang="en-US" sz="1650" dirty="0">
+                <a:solidFill>
+                  <a:srgbClr val="5B6470"/>
+                </a:solidFill>
+                <a:latin typeface="Calibri"/>
+                <a:ea typeface="Calibri"/>
+                <a:cs typeface="Calibri"/>
+              </a:rPr>
+              <a:t> </a:t>
+            </a:r>
+            <a:r>
+              <a:rPr lang="en-US" sz="1650" dirty="0" err="1">
+                <a:solidFill>
+                  <a:srgbClr val="5B6470"/>
+                </a:solidFill>
+                <a:latin typeface="Calibri"/>
+                <a:ea typeface="Calibri"/>
+                <a:cs typeface="Calibri"/>
+              </a:rPr>
+              <a:t>lourde</a:t>
+            </a:r>
+            <a:r>
+              <a:rPr lang="en-US" sz="1650" dirty="0">
+                <a:solidFill>
+                  <a:srgbClr val="5B6470"/>
+                </a:solidFill>
+                <a:latin typeface="Calibri"/>
+                <a:ea typeface="Calibri"/>
+                <a:cs typeface="Calibri"/>
+              </a:rPr>
+              <a:t> (</a:t>
+            </a:r>
+            <a:r>
+              <a:rPr lang="en-US" sz="1650" dirty="0" err="1">
+                <a:solidFill>
+                  <a:srgbClr val="5B6470"/>
+                </a:solidFill>
+                <a:latin typeface="Calibri"/>
+                <a:ea typeface="Calibri"/>
+                <a:cs typeface="Calibri"/>
+              </a:rPr>
+              <a:t>amende</a:t>
+            </a:r>
+            <a:r>
+              <a:rPr lang="en-US" sz="1650" dirty="0">
+                <a:solidFill>
+                  <a:srgbClr val="5B6470"/>
+                </a:solidFill>
+                <a:latin typeface="Calibri"/>
+                <a:ea typeface="Calibri"/>
+                <a:cs typeface="Calibri"/>
+              </a:rPr>
+              <a:t>, </a:t>
+            </a:r>
+            <a:r>
+              <a:rPr lang="en-US" sz="1650" dirty="0" err="1">
+                <a:solidFill>
+                  <a:srgbClr val="5B6470"/>
+                </a:solidFill>
+                <a:latin typeface="Calibri"/>
+                <a:ea typeface="Calibri"/>
+                <a:cs typeface="Calibri"/>
+              </a:rPr>
+              <a:t>blocage</a:t>
+            </a:r>
+            <a:r>
+              <a:rPr lang="en-US" sz="1650" dirty="0">
+                <a:solidFill>
+                  <a:srgbClr val="5B6470"/>
+                </a:solidFill>
+                <a:latin typeface="Calibri"/>
+                <a:ea typeface="Calibri"/>
+                <a:cs typeface="Calibri"/>
+              </a:rPr>
+              <a:t>) </a:t>
+            </a:r>
+            <a:r>
+              <a:rPr lang="en-US" sz="1650" dirty="0" err="1">
+                <a:solidFill>
+                  <a:srgbClr val="5B6470"/>
+                </a:solidFill>
+                <a:latin typeface="Calibri"/>
+                <a:ea typeface="Calibri"/>
+                <a:cs typeface="Calibri"/>
+              </a:rPr>
+              <a:t>prise</a:t>
+            </a:r>
+            <a:r>
+              <a:rPr lang="en-US" sz="1650" dirty="0">
+                <a:solidFill>
+                  <a:srgbClr val="5B6470"/>
+                </a:solidFill>
+                <a:latin typeface="Calibri"/>
+                <a:ea typeface="Calibri"/>
+                <a:cs typeface="Calibri"/>
+              </a:rPr>
+              <a:t> par </a:t>
+            </a:r>
+            <a:r>
+              <a:rPr lang="en-US" sz="1650" dirty="0" err="1">
+                <a:solidFill>
+                  <a:srgbClr val="5B6470"/>
+                </a:solidFill>
+                <a:latin typeface="Calibri"/>
+                <a:ea typeface="Calibri"/>
+                <a:cs typeface="Calibri"/>
+              </a:rPr>
+              <a:t>l'algorithme</a:t>
+            </a:r>
+            <a:r>
+              <a:rPr lang="en-US" sz="1650" dirty="0">
+                <a:solidFill>
+                  <a:srgbClr val="5B6470"/>
+                </a:solidFill>
+                <a:latin typeface="Calibri"/>
+                <a:ea typeface="Calibri"/>
+                <a:cs typeface="Calibri"/>
+              </a:rPr>
+              <a:t> seul.</a:t>
+            </a:r>
+            <a:endParaRPr lang="en-US" sz="1650" dirty="0"/>
           </a:p>
         </p:txBody>
       </p:sp>
@@ -3595,7 +4060,7 @@
         </p:nvSpPr>
         <p:spPr bwMode="auto">
           <a:xfrm>
-            <a:off x="1417320" y="4210812"/>
+            <a:off x="1356360" y="5262371"/>
             <a:ext cx="10058400" cy="768096"/>
           </a:xfrm>
           <a:prstGeom prst="rect">
@@ -3616,7 +4081,7 @@
               <a:defRPr/>
             </a:pPr>
             <a:r>
-              <a:rPr lang="en-US" sz="1650" b="1">
+              <a:rPr lang="en-US" sz="1650" b="1" dirty="0">
                 <a:solidFill>
                   <a:srgbClr val="1F2328"/>
                 </a:solidFill>
@@ -3624,10 +4089,54 @@
                 <a:ea typeface="Calibri"/>
                 <a:cs typeface="Calibri"/>
               </a:rPr>
-              <a:t>Lutte contre les biais :</a:t>
-            </a:r>
-            <a:r>
-              <a:rPr lang="en-US" sz="1650">
+              <a:t>Lutte </a:t>
+            </a:r>
+            <a:r>
+              <a:rPr lang="en-US" sz="1650" b="1" dirty="0" err="1">
+                <a:solidFill>
+                  <a:srgbClr val="1F2328"/>
+                </a:solidFill>
+                <a:latin typeface="Calibri"/>
+                <a:ea typeface="Calibri"/>
+                <a:cs typeface="Calibri"/>
+              </a:rPr>
+              <a:t>contre</a:t>
+            </a:r>
+            <a:r>
+              <a:rPr lang="en-US" sz="1650" b="1" dirty="0">
+                <a:solidFill>
+                  <a:srgbClr val="1F2328"/>
+                </a:solidFill>
+                <a:latin typeface="Calibri"/>
+                <a:ea typeface="Calibri"/>
+                <a:cs typeface="Calibri"/>
+              </a:rPr>
+              <a:t> les </a:t>
+            </a:r>
+            <a:r>
+              <a:rPr lang="en-US" sz="1650" b="1" dirty="0" err="1">
+                <a:solidFill>
+                  <a:srgbClr val="1F2328"/>
+                </a:solidFill>
+                <a:latin typeface="Calibri"/>
+                <a:ea typeface="Calibri"/>
+                <a:cs typeface="Calibri"/>
+              </a:rPr>
+              <a:t>biais</a:t>
+            </a:r>
+            <a:r>
+              <a:rPr lang="en-US" sz="1650" b="1" dirty="0">
+                <a:solidFill>
+                  <a:srgbClr val="1F2328"/>
+                </a:solidFill>
+                <a:latin typeface="Calibri"/>
+                <a:ea typeface="Calibri"/>
+                <a:cs typeface="Calibri"/>
+              </a:rPr>
+              <a:t> :</a:t>
+            </a:r>
+            <a:r>
+              <a:rPr lang="en-US" sz="1650" dirty="0">
                 <a:solidFill>
                   <a:srgbClr val="5B6470"/>
                 </a:solidFill>
@@ -3635,9 +4144,97 @@
                 <a:ea typeface="Calibri"/>
                 <a:cs typeface="Calibri"/>
               </a:rPr>
-              <a:t>  audits pour ne pas désavantager selon le revenu, l'âge, le quartier, le handicap.</a:t>
-            </a:r>
-            <a:endParaRPr lang="en-US" sz="1650"/>
+              <a:t>  audits pour ne pas </a:t>
+            </a:r>
+            <a:r>
+              <a:rPr lang="en-US" sz="1650" dirty="0" err="1">
+                <a:solidFill>
+                  <a:srgbClr val="5B6470"/>
+                </a:solidFill>
+                <a:latin typeface="Calibri"/>
+                <a:ea typeface="Calibri"/>
+                <a:cs typeface="Calibri"/>
+              </a:rPr>
+              <a:t>désavantager</a:t>
+            </a:r>
+            <a:r>
+              <a:rPr lang="en-US" sz="1650" dirty="0">
+                <a:solidFill>
+                  <a:srgbClr val="5B6470"/>
+                </a:solidFill>
+                <a:latin typeface="Calibri"/>
+                <a:ea typeface="Calibri"/>
+                <a:cs typeface="Calibri"/>
+              </a:rPr>
+              <a:t> </a:t>
+            </a:r>
+            <a:r>
+              <a:rPr lang="en-US" sz="1650" dirty="0" err="1">
+                <a:solidFill>
+                  <a:srgbClr val="5B6470"/>
+                </a:solidFill>
+                <a:latin typeface="Calibri"/>
+                <a:ea typeface="Calibri"/>
+                <a:cs typeface="Calibri"/>
+              </a:rPr>
+              <a:t>selon</a:t>
+            </a:r>
+            <a:r>
+              <a:rPr lang="en-US" sz="1650" dirty="0">
+                <a:solidFill>
+                  <a:srgbClr val="5B6470"/>
+                </a:solidFill>
+                <a:latin typeface="Calibri"/>
+                <a:ea typeface="Calibri"/>
+                <a:cs typeface="Calibri"/>
+              </a:rPr>
+              <a:t> le </a:t>
+            </a:r>
+            <a:r>
+              <a:rPr lang="en-US" sz="1650" dirty="0" err="1">
+                <a:solidFill>
+                  <a:srgbClr val="5B6470"/>
+                </a:solidFill>
+                <a:latin typeface="Calibri"/>
+                <a:ea typeface="Calibri"/>
+                <a:cs typeface="Calibri"/>
+              </a:rPr>
+              <a:t>revenu</a:t>
+            </a:r>
+            <a:r>
+              <a:rPr lang="en-US" sz="1650" dirty="0">
+                <a:solidFill>
+                  <a:srgbClr val="5B6470"/>
+                </a:solidFill>
+                <a:latin typeface="Calibri"/>
+                <a:ea typeface="Calibri"/>
+                <a:cs typeface="Calibri"/>
+              </a:rPr>
+              <a:t>, </a:t>
+            </a:r>
+            <a:r>
+              <a:rPr lang="en-US" sz="1650" dirty="0" err="1">
+                <a:solidFill>
+                  <a:srgbClr val="5B6470"/>
+                </a:solidFill>
+                <a:latin typeface="Calibri"/>
+                <a:ea typeface="Calibri"/>
+                <a:cs typeface="Calibri"/>
+              </a:rPr>
+              <a:t>l'âge</a:t>
+            </a:r>
+            <a:r>
+              <a:rPr lang="en-US" sz="1650" dirty="0">
+                <a:solidFill>
+                  <a:srgbClr val="5B6470"/>
+                </a:solidFill>
+                <a:latin typeface="Calibri"/>
+                <a:ea typeface="Calibri"/>
+                <a:cs typeface="Calibri"/>
+              </a:rPr>
+              <a:t>, le quartier, le handicap.</a:t>
+            </a:r>
+            <a:endParaRPr lang="en-US" sz="1650" dirty="0"/>
           </a:p>
         </p:txBody>
       </p:sp>
@@ -3716,7 +4313,7 @@
         </p:nvSpPr>
         <p:spPr bwMode="auto">
           <a:xfrm>
-            <a:off x="1417320" y="5262372"/>
+            <a:off x="1389888" y="4208493"/>
             <a:ext cx="10058400" cy="768096"/>
           </a:xfrm>
           <a:prstGeom prst="rect">
@@ -3737,7 +4334,7 @@
               <a:defRPr/>
             </a:pPr>
             <a:r>
-              <a:rPr lang="en-US" sz="1650" b="1">
+              <a:rPr lang="en-US" sz="1650" b="1" dirty="0">
                 <a:solidFill>
                   <a:srgbClr val="1F2328"/>
                 </a:solidFill>
@@ -3745,10 +4342,32 @@
                 <a:ea typeface="Calibri"/>
                 <a:cs typeface="Calibri"/>
               </a:rPr>
-              <a:t>L'IA assiste,</a:t>
-            </a:r>
-            <a:r>
-              <a:rPr lang="en-US" sz="1650">
+              <a:t>L'IA </a:t>
+            </a:r>
+            <a:r>
+              <a:rPr lang="en-US" sz="1650" b="1" dirty="0" err="1">
+                <a:solidFill>
+                  <a:srgbClr val="1F2328"/>
+                </a:solidFill>
+                <a:latin typeface="Calibri"/>
+                <a:ea typeface="Calibri"/>
+                <a:cs typeface="Calibri"/>
+              </a:rPr>
+              <a:t>assiste</a:t>
+            </a:r>
+            <a:r>
+              <a:rPr lang="en-US" sz="1650" b="1" dirty="0">
+                <a:solidFill>
+                  <a:srgbClr val="1F2328"/>
+                </a:solidFill>
+                <a:latin typeface="Calibri"/>
+                <a:ea typeface="Calibri"/>
+                <a:cs typeface="Calibri"/>
+              </a:rPr>
+              <a:t>,</a:t>
+            </a:r>
+            <a:r>
+              <a:rPr lang="en-US" sz="1650" dirty="0">
                 <a:solidFill>
                   <a:srgbClr val="5B6470"/>
                 </a:solidFill>
@@ -3756,9 +4375,158 @@
                 <a:ea typeface="Calibri"/>
                 <a:cs typeface="Calibri"/>
               </a:rPr>
-              <a:t>  elle ne remplace pas le jugement humain.</a:t>
-            </a:r>
-            <a:endParaRPr lang="en-US" sz="1650"/>
+              <a:t>  </a:t>
+            </a:r>
+            <a:r>
+              <a:rPr lang="en-US" sz="1650" dirty="0" err="1">
+                <a:solidFill>
+                  <a:srgbClr val="5B6470"/>
+                </a:solidFill>
+                <a:latin typeface="Calibri"/>
+                <a:ea typeface="Calibri"/>
+                <a:cs typeface="Calibri"/>
+              </a:rPr>
+              <a:t>elle</a:t>
+            </a:r>
+            <a:r>
+              <a:rPr lang="en-US" sz="1650" dirty="0">
+                <a:solidFill>
+                  <a:srgbClr val="5B6470"/>
+                </a:solidFill>
+                <a:latin typeface="Calibri"/>
+                <a:ea typeface="Calibri"/>
+                <a:cs typeface="Calibri"/>
+              </a:rPr>
+              <a:t> ne </a:t>
+            </a:r>
+            <a:r>
+              <a:rPr lang="en-US" sz="1650" dirty="0" err="1">
+                <a:solidFill>
+                  <a:srgbClr val="5B6470"/>
+                </a:solidFill>
+                <a:latin typeface="Calibri"/>
+                <a:ea typeface="Calibri"/>
+                <a:cs typeface="Calibri"/>
+              </a:rPr>
+              <a:t>remplace</a:t>
+            </a:r>
+            <a:r>
+              <a:rPr lang="en-US" sz="1650" dirty="0">
+                <a:solidFill>
+                  <a:srgbClr val="5B6470"/>
+                </a:solidFill>
+                <a:latin typeface="Calibri"/>
+                <a:ea typeface="Calibri"/>
+                <a:cs typeface="Calibri"/>
+              </a:rPr>
+              <a:t> pas le </a:t>
+            </a:r>
+            <a:r>
+              <a:rPr lang="en-US" sz="1650" dirty="0" err="1">
+                <a:solidFill>
+                  <a:srgbClr val="5B6470"/>
+                </a:solidFill>
+                <a:latin typeface="Calibri"/>
+                <a:ea typeface="Calibri"/>
+                <a:cs typeface="Calibri"/>
+              </a:rPr>
+              <a:t>jugement</a:t>
+            </a:r>
+            <a:r>
+              <a:rPr lang="en-US" sz="1650" dirty="0">
+                <a:solidFill>
+                  <a:srgbClr val="5B6470"/>
+                </a:solidFill>
+                <a:latin typeface="Calibri"/>
+                <a:ea typeface="Calibri"/>
+                <a:cs typeface="Calibri"/>
+              </a:rPr>
+              <a:t> </a:t>
+            </a:r>
+            <a:r>
+              <a:rPr lang="en-US" sz="1650" dirty="0" err="1">
+                <a:solidFill>
+                  <a:srgbClr val="5B6470"/>
+                </a:solidFill>
+                <a:latin typeface="Calibri"/>
+                <a:ea typeface="Calibri"/>
+                <a:cs typeface="Calibri"/>
+              </a:rPr>
+              <a:t>humain</a:t>
+            </a:r>
+            <a:r>
+              <a:rPr lang="en-US" sz="1650" dirty="0">
+                <a:solidFill>
+                  <a:srgbClr val="5B6470"/>
+                </a:solidFill>
+                <a:latin typeface="Calibri"/>
+                <a:ea typeface="Calibri"/>
+                <a:cs typeface="Calibri"/>
+              </a:rPr>
+              <a:t>.</a:t>
+            </a:r>
+            <a:endParaRPr lang="en-US" sz="1650" baseline="30000" dirty="0"/>
+          </a:p>
+        </p:txBody>
+      </p:sp>
+      <p:sp>
+        <p:nvSpPr>
+          <p:cNvPr id="2" name="ZoneTexte 1">
+            <a:extLst>
+              <a:ext uri="{FF2B5EF4-FFF2-40B4-BE49-F238E27FC236}">
+                <a16:creationId xmlns:a16="http://schemas.microsoft.com/office/drawing/2014/main" id="{7341BCD7-27BE-4AE9-510D-1A98B8E84F6E}"/>
+              </a:ext>
+            </a:extLst>
+          </p:cNvPr>
+          <p:cNvSpPr txBox="1"/>
+          <p:nvPr/>
+        </p:nvSpPr>
+        <p:spPr>
+          <a:xfrm>
+            <a:off x="171692" y="6428296"/>
+            <a:ext cx="5670509" cy="415498"/>
+          </a:xfrm>
+          <a:prstGeom prst="rect">
+            <a:avLst/>
+          </a:prstGeom>
+          <a:noFill/>
+        </p:spPr>
+        <p:txBody>
+          <a:bodyPr wrap="square" rtlCol="0">
+            <a:spAutoFit/>
+          </a:bodyPr>
+          <a:lstStyle/>
+          <a:p>
+            <a:r>
+              <a:rPr lang="fr-CH" sz="700" dirty="0"/>
+              <a:t>[1] </a:t>
+            </a:r>
+            <a:r>
+              <a:rPr lang="fr-CH" sz="700" dirty="0">
+                <a:hlinkClick r:id="rId4"/>
+              </a:rPr>
+              <a:t>https://www.rts.ch/info/suisse/2025/article/billets-de-train-trop-chers-l-erreur-qui-penalise-les-abonnes-regionaux-29052779.html</a:t>
+            </a:r>
+            <a:endParaRPr lang="fr-CH" sz="700" dirty="0"/>
+          </a:p>
+          <a:p>
+            <a:r>
+              <a:rPr lang="fr-CH" sz="700" dirty="0"/>
+              <a:t>[2] </a:t>
+            </a:r>
+            <a:r>
+              <a:rPr lang="fr-CH" sz="700" dirty="0">
+                <a:hlinkClick r:id="rId5"/>
+              </a:rPr>
+              <a:t>https://www.sbb.ch/fr/aide-et-contact/chatbot.html</a:t>
+            </a:r>
+            <a:endParaRPr lang="fr-CH" sz="700" dirty="0"/>
+          </a:p>
+          <a:p>
+            <a:r>
+              <a:rPr lang="fr-CH" sz="700" dirty="0"/>
+              <a:t> </a:t>
+            </a:r>
           </a:p>
         </p:txBody>
       </p:sp>
@@ -4057,7 +4825,7 @@
               <a:defRPr/>
             </a:pPr>
             <a:r>
-              <a:rPr lang="en-US" sz="1650" b="1">
+              <a:rPr lang="en-US" sz="1650" b="1" dirty="0" err="1">
                 <a:solidFill>
                   <a:srgbClr val="1F2328"/>
                 </a:solidFill>
@@ -4065,10 +4833,43 @@
                 <a:ea typeface="Calibri"/>
                 <a:cs typeface="Calibri"/>
               </a:rPr>
-              <a:t>Collecte minimale,</a:t>
-            </a:r>
-            <a:r>
-              <a:rPr lang="en-US" sz="1650">
+              <a:t>Collecte</a:t>
+            </a:r>
+            <a:r>
+              <a:rPr lang="en-US" sz="1650" b="1" dirty="0">
+                <a:solidFill>
+                  <a:srgbClr val="1F2328"/>
+                </a:solidFill>
+                <a:latin typeface="Calibri"/>
+                <a:ea typeface="Calibri"/>
+                <a:cs typeface="Calibri"/>
+              </a:rPr>
+              <a:t> </a:t>
+            </a:r>
+            <a:r>
+              <a:rPr lang="en-US" sz="1650" b="1" dirty="0" err="1">
+                <a:solidFill>
+                  <a:srgbClr val="1F2328"/>
+                </a:solidFill>
+                <a:latin typeface="Calibri"/>
+                <a:ea typeface="Calibri"/>
+                <a:cs typeface="Calibri"/>
+              </a:rPr>
+              <a:t>minimale</a:t>
+            </a:r>
+            <a:r>
+              <a:rPr lang="en-US" sz="1650" b="1" dirty="0">
+                <a:solidFill>
+                  <a:srgbClr val="1F2328"/>
+                </a:solidFill>
+                <a:latin typeface="Calibri"/>
+                <a:ea typeface="Calibri"/>
+                <a:cs typeface="Calibri"/>
+              </a:rPr>
+              <a:t>,</a:t>
+            </a:r>
+            <a:r>
+              <a:rPr lang="en-US" sz="1650" dirty="0">
                 <a:solidFill>
                   <a:srgbClr val="5B6470"/>
                 </a:solidFill>
@@ -4076,9 +4877,163 @@
                 <a:ea typeface="Calibri"/>
                 <a:cs typeface="Calibri"/>
               </a:rPr>
-              <a:t>  finalité limitée, données hébergées en Suisse.</a:t>
-            </a:r>
-            <a:endParaRPr lang="en-US" sz="1650"/>
+              <a:t>  </a:t>
+            </a:r>
+            <a:r>
+              <a:rPr lang="en-US" sz="1650" dirty="0" err="1">
+                <a:solidFill>
+                  <a:srgbClr val="5B6470"/>
+                </a:solidFill>
+                <a:latin typeface="Calibri"/>
+                <a:ea typeface="Calibri"/>
+                <a:cs typeface="Calibri"/>
+              </a:rPr>
+              <a:t>finalité</a:t>
+            </a:r>
+            <a:r>
+              <a:rPr lang="en-US" sz="1650" dirty="0">
+                <a:solidFill>
+                  <a:srgbClr val="5B6470"/>
+                </a:solidFill>
+                <a:latin typeface="Calibri"/>
+                <a:ea typeface="Calibri"/>
+                <a:cs typeface="Calibri"/>
+              </a:rPr>
+              <a:t> </a:t>
+            </a:r>
+            <a:r>
+              <a:rPr lang="en-US" sz="1650" dirty="0" err="1">
+                <a:solidFill>
+                  <a:srgbClr val="5B6470"/>
+                </a:solidFill>
+                <a:latin typeface="Calibri"/>
+                <a:ea typeface="Calibri"/>
+                <a:cs typeface="Calibri"/>
+              </a:rPr>
+              <a:t>limitée</a:t>
+            </a:r>
+            <a:r>
+              <a:rPr lang="en-US" sz="1650" dirty="0">
+                <a:solidFill>
+                  <a:srgbClr val="5B6470"/>
+                </a:solidFill>
+                <a:latin typeface="Calibri"/>
+                <a:ea typeface="Calibri"/>
+                <a:cs typeface="Calibri"/>
+              </a:rPr>
+              <a:t>, données </a:t>
+            </a:r>
+            <a:r>
+              <a:rPr lang="en-US" sz="1650" dirty="0" err="1">
+                <a:solidFill>
+                  <a:srgbClr val="5B6470"/>
+                </a:solidFill>
+                <a:latin typeface="Calibri"/>
+                <a:ea typeface="Calibri"/>
+                <a:cs typeface="Calibri"/>
+              </a:rPr>
+              <a:t>hébergées</a:t>
+            </a:r>
+            <a:r>
+              <a:rPr lang="en-US" sz="1650" dirty="0">
+                <a:solidFill>
+                  <a:srgbClr val="5B6470"/>
+                </a:solidFill>
+                <a:latin typeface="Calibri"/>
+                <a:ea typeface="Calibri"/>
+                <a:cs typeface="Calibri"/>
+              </a:rPr>
+              <a:t> </a:t>
+            </a:r>
+            <a:r>
+              <a:rPr lang="en-US" sz="1650" dirty="0" err="1">
+                <a:solidFill>
+                  <a:srgbClr val="5B6470"/>
+                </a:solidFill>
+                <a:latin typeface="Calibri"/>
+                <a:ea typeface="Calibri"/>
+                <a:cs typeface="Calibri"/>
+              </a:rPr>
+              <a:t>si</a:t>
+            </a:r>
+            <a:r>
+              <a:rPr lang="en-US" sz="1650" dirty="0">
+                <a:solidFill>
+                  <a:srgbClr val="5B6470"/>
+                </a:solidFill>
+                <a:latin typeface="Calibri"/>
+                <a:ea typeface="Calibri"/>
+                <a:cs typeface="Calibri"/>
+              </a:rPr>
+              <a:t> possible </a:t>
+            </a:r>
+            <a:r>
+              <a:rPr lang="en-US" sz="1650" dirty="0" err="1">
+                <a:solidFill>
+                  <a:srgbClr val="5B6470"/>
+                </a:solidFill>
+                <a:latin typeface="Calibri"/>
+                <a:ea typeface="Calibri"/>
+                <a:cs typeface="Calibri"/>
+              </a:rPr>
+              <a:t>en</a:t>
+            </a:r>
+            <a:r>
+              <a:rPr lang="en-US" sz="1650" dirty="0">
+                <a:solidFill>
+                  <a:srgbClr val="5B6470"/>
+                </a:solidFill>
+                <a:latin typeface="Calibri"/>
+                <a:ea typeface="Calibri"/>
+                <a:cs typeface="Calibri"/>
+              </a:rPr>
+              <a:t> Suisse </a:t>
+            </a:r>
+            <a:r>
+              <a:rPr lang="en-US" sz="1650" dirty="0" err="1">
+                <a:solidFill>
+                  <a:srgbClr val="5B6470"/>
+                </a:solidFill>
+                <a:latin typeface="Calibri"/>
+                <a:ea typeface="Calibri"/>
+                <a:cs typeface="Calibri"/>
+              </a:rPr>
+              <a:t>ou</a:t>
+            </a:r>
+            <a:r>
+              <a:rPr lang="en-US" sz="1650" dirty="0">
+                <a:solidFill>
+                  <a:srgbClr val="5B6470"/>
+                </a:solidFill>
+                <a:latin typeface="Calibri"/>
+                <a:ea typeface="Calibri"/>
+                <a:cs typeface="Calibri"/>
+              </a:rPr>
+              <a:t> </a:t>
+            </a:r>
+            <a:r>
+              <a:rPr lang="en-US" sz="1650" dirty="0" err="1">
+                <a:solidFill>
+                  <a:srgbClr val="5B6470"/>
+                </a:solidFill>
+                <a:latin typeface="Calibri"/>
+                <a:ea typeface="Calibri"/>
+                <a:cs typeface="Calibri"/>
+              </a:rPr>
+              <a:t>en</a:t>
+            </a:r>
+            <a:r>
+              <a:rPr lang="en-US" sz="1650" dirty="0">
+                <a:solidFill>
+                  <a:srgbClr val="5B6470"/>
+                </a:solidFill>
+                <a:latin typeface="Calibri"/>
+                <a:ea typeface="Calibri"/>
+                <a:cs typeface="Calibri"/>
+              </a:rPr>
+              <a:t> Europe.</a:t>
+            </a:r>
+            <a:endParaRPr lang="en-US" sz="1650" dirty="0"/>
           </a:p>
         </p:txBody>
       </p:sp>
@@ -4324,100 +5279,61 @@
           <a:bodyPr wrap="square" lIns="0" tIns="0" rIns="0" bIns="0" rtlCol="0" anchor="ctr"/>
           <a:lstStyle/>
           <a:p>
-            <a:pPr marL="0" indent="0">
+            <a:pPr>
               <a:lnSpc>
                 <a:spcPct val="102000"/>
               </a:lnSpc>
-              <a:buNone/>
-              <a:defRPr/>
-            </a:pPr>
+              <a:defRPr/>
+            </a:pPr>
+            <a:r>
+              <a:rPr lang="en-US" sz="1650" b="1" dirty="0">
+                <a:solidFill>
+                  <a:srgbClr val="1F2328"/>
+                </a:solidFill>
+                <a:ea typeface="Calibri"/>
+                <a:cs typeface="Calibri"/>
+              </a:rPr>
+              <a:t>Pas de </a:t>
+            </a:r>
             <a:r>
               <a:rPr lang="en-US" sz="1650" b="1" dirty="0" err="1">
                 <a:solidFill>
                   <a:srgbClr val="1F2328"/>
                 </a:solidFill>
-                <a:latin typeface="Calibri"/>
-                <a:ea typeface="Calibri"/>
-                <a:cs typeface="Calibri"/>
-              </a:rPr>
-              <a:t>Refus</a:t>
+                <a:ea typeface="Calibri"/>
+                <a:cs typeface="Calibri"/>
+              </a:rPr>
+              <a:t>traçage</a:t>
             </a:r>
             <a:r>
               <a:rPr lang="en-US" sz="1650" b="1" dirty="0">
                 <a:solidFill>
                   <a:srgbClr val="1F2328"/>
                 </a:solidFill>
-                <a:latin typeface="Calibri"/>
-                <a:ea typeface="Calibri"/>
-                <a:cs typeface="Calibri"/>
-              </a:rPr>
-              <a:t> d'un </a:t>
-            </a:r>
-            <a:r>
-              <a:rPr lang="en-US" sz="1650" b="1" dirty="0" err="1">
-                <a:solidFill>
-                  <a:srgbClr val="1F2328"/>
-                </a:solidFill>
-                <a:latin typeface="Calibri"/>
-                <a:ea typeface="Calibri"/>
-                <a:cs typeface="Calibri"/>
-              </a:rPr>
-              <a:t>historique</a:t>
-            </a:r>
-            <a:r>
-              <a:rPr lang="en-US" sz="1650" dirty="0">
+                <a:ea typeface="Calibri"/>
+                <a:cs typeface="Calibri"/>
+              </a:rPr>
+              <a:t>,</a:t>
+            </a:r>
+            <a:r>
+              <a:rPr lang="fr-FR" sz="1650" b="1" dirty="0">
                 <a:solidFill>
                   <a:srgbClr val="5B6470"/>
                 </a:solidFill>
-                <a:latin typeface="Calibri"/>
-                <a:ea typeface="Calibri"/>
-                <a:cs typeface="Calibri"/>
-              </a:rPr>
-              <a:t>  </a:t>
-            </a:r>
-            <a:r>
-              <a:rPr lang="en-US" sz="1650" dirty="0" err="1">
+                <a:ea typeface="Calibri"/>
+                <a:cs typeface="Calibri"/>
+              </a:rPr>
+              <a:t> </a:t>
+            </a:r>
+            <a:r>
+              <a:rPr lang="fr-FR" sz="1650" dirty="0">
                 <a:solidFill>
                   <a:srgbClr val="5B6470"/>
                 </a:solidFill>
-                <a:latin typeface="Calibri"/>
-                <a:ea typeface="Calibri"/>
-                <a:cs typeface="Calibri"/>
-              </a:rPr>
-              <a:t>exhaustif</a:t>
-            </a:r>
-            <a:r>
-              <a:rPr lang="en-US" sz="1650" dirty="0">
-                <a:solidFill>
-                  <a:srgbClr val="5B6470"/>
-                </a:solidFill>
-                <a:latin typeface="Calibri"/>
-                <a:ea typeface="Calibri"/>
-                <a:cs typeface="Calibri"/>
-              </a:rPr>
-              <a:t> et permanent des </a:t>
-            </a:r>
-            <a:r>
-              <a:rPr lang="en-US" sz="1650" dirty="0" err="1">
-                <a:solidFill>
-                  <a:srgbClr val="5B6470"/>
-                </a:solidFill>
-                <a:latin typeface="Calibri"/>
-                <a:ea typeface="Calibri"/>
-                <a:cs typeface="Calibri"/>
-              </a:rPr>
-              <a:t>déplacements</a:t>
-            </a:r>
-            <a:r>
-              <a:rPr lang="en-US" sz="1650" dirty="0">
-                <a:solidFill>
-                  <a:srgbClr val="5B6470"/>
-                </a:solidFill>
-                <a:latin typeface="Calibri"/>
-                <a:ea typeface="Calibri"/>
-                <a:cs typeface="Calibri"/>
-              </a:rPr>
-              <a:t>.</a:t>
+                <a:ea typeface="Calibri"/>
+                <a:cs typeface="Calibri"/>
+              </a:rPr>
+              <a:t>de profilage ou surveillance des utilisateurs</a:t>
             </a:r>
             <a:endParaRPr lang="en-US" sz="1650" dirty="0"/>
           </a:p>
@@ -4511,13 +5427,23 @@
           <a:bodyPr wrap="square" lIns="0" tIns="0" rIns="0" bIns="0" rtlCol="0" anchor="ctr"/>
           <a:lstStyle/>
           <a:p>
-            <a:pPr marL="0" indent="0">
+            <a:pPr>
               <a:lnSpc>
                 <a:spcPct val="102000"/>
               </a:lnSpc>
-              <a:buNone/>
-              <a:defRPr/>
-            </a:pPr>
+              <a:defRPr/>
+            </a:pPr>
+            <a:r>
+              <a:rPr lang="en-US" sz="1650" b="1" dirty="0" err="1">
+                <a:solidFill>
+                  <a:srgbClr val="1F2328"/>
+                </a:solidFill>
+                <a:latin typeface="Calibri"/>
+                <a:ea typeface="Calibri"/>
+                <a:cs typeface="Calibri"/>
+              </a:rPr>
+              <a:t>Clarté</a:t>
+            </a:r>
             <a:r>
               <a:rPr lang="en-US" sz="1650" b="1" dirty="0">
                 <a:solidFill>
@@ -4527,54 +5453,10 @@
                 <a:ea typeface="Calibri"/>
                 <a:cs typeface="Calibri"/>
               </a:rPr>
-              <a:t>Pas de </a:t>
-            </a:r>
-            <a:r>
-              <a:rPr lang="en-US" sz="1650" b="1" dirty="0" err="1">
-                <a:solidFill>
-                  <a:srgbClr val="1F2328"/>
-                </a:solidFill>
-                <a:latin typeface="Calibri"/>
-                <a:ea typeface="Calibri"/>
-                <a:cs typeface="Calibri"/>
-              </a:rPr>
-              <a:t>biométrie</a:t>
-            </a:r>
-            <a:r>
-              <a:rPr lang="en-US" sz="1650" b="1" dirty="0">
-                <a:solidFill>
-                  <a:srgbClr val="1F2328"/>
-                </a:solidFill>
-                <a:latin typeface="Calibri"/>
-                <a:ea typeface="Calibri"/>
-                <a:cs typeface="Calibri"/>
-              </a:rPr>
-              <a:t> </a:t>
-            </a:r>
-            <a:r>
-              <a:rPr lang="en-US" sz="1650" b="1" dirty="0" err="1">
-                <a:solidFill>
-                  <a:srgbClr val="1F2328"/>
-                </a:solidFill>
-                <a:latin typeface="Calibri"/>
-                <a:ea typeface="Calibri"/>
-                <a:cs typeface="Calibri"/>
-              </a:rPr>
-              <a:t>imposée</a:t>
-            </a:r>
-            <a:r>
-              <a:rPr lang="en-US" sz="1650" b="1" dirty="0">
-                <a:solidFill>
-                  <a:srgbClr val="1F2328"/>
-                </a:solidFill>
-                <a:latin typeface="Calibri"/>
-                <a:ea typeface="Calibri"/>
-                <a:cs typeface="Calibri"/>
-              </a:rPr>
-              <a:t> :</a:t>
-            </a:r>
-            <a:r>
-              <a:rPr lang="en-US" sz="1650" dirty="0">
+              <a:t> et sécurité : </a:t>
+            </a:r>
+            <a:r>
+              <a:rPr lang="fr-FR" sz="1650" dirty="0">
                 <a:solidFill>
                   <a:srgbClr val="5B6470"/>
                 </a:solidFill>
@@ -4582,31 +5464,68 @@
                 <a:ea typeface="Calibri"/>
                 <a:cs typeface="Calibri"/>
               </a:rPr>
-              <a:t>  voyager de façon anonyme </a:t>
-            </a:r>
-            <a:r>
-              <a:rPr lang="en-US" sz="1650" dirty="0" err="1">
+              <a:t>t</a:t>
+            </a:r>
+            <a:r>
+              <a:rPr lang="fr-FR" sz="1650" dirty="0">
                 <a:solidFill>
                   <a:srgbClr val="5B6470"/>
                 </a:solidFill>
-                <a:latin typeface="Calibri"/>
-                <a:ea typeface="Calibri"/>
-                <a:cs typeface="Calibri"/>
-              </a:rPr>
-              <a:t>reste</a:t>
-            </a:r>
-            <a:r>
-              <a:rPr lang="en-US" sz="1650" dirty="0">
-                <a:solidFill>
-                  <a:srgbClr val="5B6470"/>
-                </a:solidFill>
-                <a:latin typeface="Calibri"/>
-                <a:ea typeface="Calibri"/>
-                <a:cs typeface="Calibri"/>
-              </a:rPr>
-              <a:t> possible.</a:t>
-            </a:r>
-            <a:endParaRPr lang="en-US" sz="1650" dirty="0"/>
+                <a:ea typeface="Calibri"/>
+                <a:cs typeface="Calibri"/>
+              </a:rPr>
+              <a:t>ransparence sur les données collectées</a:t>
+            </a:r>
+            <a:endParaRPr lang="fr-CH" sz="1650" b="1" dirty="0">
+              <a:solidFill>
+                <a:srgbClr val="1F2328"/>
+              </a:solidFill>
+              <a:latin typeface="Calibri"/>
+              <a:ea typeface="Calibri"/>
+              <a:cs typeface="Calibri"/>
+            </a:endParaRPr>
+          </a:p>
+        </p:txBody>
+      </p:sp>
+      <p:sp>
+        <p:nvSpPr>
+          <p:cNvPr id="10" name="ZoneTexte 9">
+            <a:extLst>
+              <a:ext uri="{FF2B5EF4-FFF2-40B4-BE49-F238E27FC236}">
+                <a16:creationId xmlns:a16="http://schemas.microsoft.com/office/drawing/2014/main" id="{CB22C43A-645E-E46F-FD70-2B0B7D1A6839}"/>
+              </a:ext>
+            </a:extLst>
+          </p:cNvPr>
+          <p:cNvSpPr txBox="1"/>
+          <p:nvPr/>
+        </p:nvSpPr>
+        <p:spPr bwMode="auto">
+          <a:xfrm>
+            <a:off x="171692" y="6428296"/>
+            <a:ext cx="5670509" cy="200055"/>
+          </a:xfrm>
+          <a:prstGeom prst="rect">
+            <a:avLst/>
+          </a:prstGeom>
+          <a:noFill/>
+        </p:spPr>
+        <p:txBody>
+          <a:bodyPr wrap="square" rtlCol="0">
+            <a:spAutoFit/>
+          </a:bodyPr>
+          <a:lstStyle/>
+          <a:p>
+            <a:r>
+              <a:rPr lang="fr-CH" sz="700" dirty="0"/>
+              <a:t>[1] </a:t>
+            </a:r>
+            <a:r>
+              <a:rPr lang="fr-CH" sz="700" dirty="0">
+                <a:hlinkClick r:id="rId4"/>
+              </a:rPr>
+              <a:t>https://www.rts.ch/info/suisse/13789416-les-cff-veulent-equiper-leurs-gares-de-cameras-a-reconnaissance-faciale.html</a:t>
+            </a:r>
+            <a:endParaRPr lang="fr-CH" sz="700" dirty="0"/>
           </a:p>
         </p:txBody>
       </p:sp>
@@ -6695,4 +7614,319 @@
     </a:ext>
   </a:extLst>
 </a:theme>
+</file>
+
+<file path=ppt/theme/theme3.xml><?xml version="1.0" encoding="utf-8"?>
+<a:theme xmlns:a="http://schemas.openxmlformats.org/drawingml/2006/main" name="Thème Office">
+  <a:themeElements>
+    <a:clrScheme name="Office">
+      <a:dk1>
+        <a:sysClr val="windowText" lastClr="000000"/>
+      </a:dk1>
+      <a:lt1>
+        <a:sysClr val="window" lastClr="FFFFFF"/>
+      </a:lt1>
+      <a:dk2>
+        <a:srgbClr val="0E2841"/>
+      </a:dk2>
+      <a:lt2>
+        <a:srgbClr val="E8E8E8"/>
+      </a:lt2>
+      <a:accent1>
+        <a:srgbClr val="156082"/>
+      </a:accent1>
+      <a:accent2>
+        <a:srgbClr val="E97132"/>
+      </a:accent2>
+      <a:accent3>
+        <a:srgbClr val="196B24"/>
+      </a:accent3>
+      <a:accent4>
+        <a:srgbClr val="0F9ED5"/>
+      </a:accent4>
+      <a:accent5>
+        <a:srgbClr val="A02B93"/>
+      </a:accent5>
+      <a:accent6>
+        <a:srgbClr val="4EA72E"/>
+      </a:accent6>
+      <a:hlink>
+        <a:srgbClr val="467886"/>
+      </a:hlink>
+      <a:folHlink>
+        <a:srgbClr val="96607D"/>
+      </a:folHlink>
+    </a:clrScheme>
+    <a:fontScheme name="Office">
+      <a:majorFont>
+        <a:latin typeface="Aptos Display" panose="02110004020202020204"/>
+        <a:ea typeface=""/>
+        <a:cs typeface=""/>
+        <a:font script="Jpan" typeface="游ゴシック Light"/>
+        <a:font script="Hang" typeface="맑은 고딕"/>
+        <a:font script="Hans" typeface="等线 Light"/>
+        <a:font script="Hant" typeface="新細明體"/>
+        <a:font script="Arab" typeface="Times New Roman"/>
+        <a:font script="Hebr" typeface="Times New Roman"/>
+        <a:font script="Thai" typeface="Angsana New"/>
+        <a:font script="Ethi" typeface="Nyala"/>
+        <a:font script="Beng" typeface="Vrinda"/>
+        <a:font script="Gujr" typeface="Shruti"/>
+        <a:font script="Khmr" typeface="MoolBoran"/>
+        <a:font script="Knda" typeface="Tunga"/>
+        <a:font script="Guru" typeface="Raavi"/>
+        <a:font script="Cans" typeface="Euphemia"/>
+        <a:font script="Cher" typeface="Plantagenet Cherokee"/>
+        <a:font script="Yiii" typeface="Microsoft Yi Baiti"/>
+        <a:font script="Tibt" typeface="Microsoft Himalaya"/>
+        <a:font script="Thaa" typeface="MV Boli"/>
+        <a:font script="Deva" typeface="Mangal"/>
+        <a:font script="Telu" typeface="Gautami"/>
+        <a:font script="Taml" typeface="Latha"/>
+        <a:font script="Syrc" typeface="Estrangelo Edessa"/>
+        <a:font script="Orya" typeface="Kalinga"/>
+        <a:font script="Mlym" typeface="Kartika"/>
+        <a:font script="Laoo" typeface="DokChampa"/>
+        <a:font script="Sinh" typeface="Iskoola Pota"/>
+        <a:font script="Mong" typeface="Mongolian Baiti"/>
+        <a:font script="Viet" typeface="Times New Roman"/>
+        <a:font script="Uigh" typeface="Microsoft Uighur"/>
+        <a:font script="Geor" typeface="Sylfaen"/>
+        <a:font script="Armn" typeface="Arial"/>
+        <a:font script="Bugi" typeface="Leelawadee UI"/>
+        <a:font script="Bopo" typeface="Microsoft JhengHei"/>
+        <a:font script="Java" typeface="Javanese Text"/>
+        <a:font script="Lisu" typeface="Segoe UI"/>
+        <a:font script="Mymr" typeface="Myanmar Text"/>
+        <a:font script="Nkoo" typeface="Ebrima"/>
+        <a:font script="Olck" typeface="Nirmala UI"/>
+        <a:font script="Osma" typeface="Ebrima"/>
+        <a:font script="Phag" typeface="Phagspa"/>
+        <a:font script="Syrn" typeface="Estrangelo Edessa"/>
+        <a:font script="Syrj" typeface="Estrangelo Edessa"/>
+        <a:font script="Syre" typeface="Estrangelo Edessa"/>
+        <a:font script="Sora" typeface="Nirmala UI"/>
+        <a:font script="Tale" typeface="Microsoft Tai Le"/>
+        <a:font script="Talu" typeface="Microsoft New Tai Lue"/>
+        <a:font script="Tfng" typeface="Ebrima"/>
+      </a:majorFont>
+      <a:minorFont>
+        <a:latin typeface="Aptos" panose="02110004020202020204"/>
+        <a:ea typeface=""/>
+        <a:cs typeface=""/>
+        <a:font script="Jpan" typeface="游ゴシック"/>
+        <a:font script="Hang" typeface="맑은 고딕"/>
+        <a:font script="Hans" typeface="等线"/>
+        <a:font script="Hant" typeface="新細明體"/>
+        <a:font script="Arab" typeface="Arial"/>
+        <a:font script="Hebr" typeface="Arial"/>
+        <a:font script="Thai" typeface="Cordia New"/>
+        <a:font script="Ethi" typeface="Nyala"/>
+        <a:font script="Beng" typeface="Vrinda"/>
+        <a:font script="Gujr" typeface="Shruti"/>
+        <a:font script="Khmr" typeface="DaunPenh"/>
+        <a:font script="Knda" typeface="Tunga"/>
+        <a:font script="Guru" typeface="Raavi"/>
+        <a:font script="Cans" typeface="Euphemia"/>
+        <a:font script="Cher" typeface="Plantagenet Cherokee"/>
+        <a:font script="Yiii" typeface="Microsoft Yi Baiti"/>
+        <a:font script="Tibt" typeface="Microsoft Himalaya"/>
+        <a:font script="Thaa" typeface="MV Boli"/>
+        <a:font script="Deva" typeface="Mangal"/>
+        <a:font script="Telu" typeface="Gautami"/>
+        <a:font script="Taml" typeface="Latha"/>
+        <a:font script="Syrc" typeface="Estrangelo Edessa"/>
+        <a:font script="Orya" typeface="Kalinga"/>
+        <a:font script="Mlym" typeface="Kartika"/>
+        <a:font script="Laoo" typeface="DokChampa"/>
+        <a:font script="Sinh" typeface="Iskoola Pota"/>
+        <a:font script="Mong" typeface="Mongolian Baiti"/>
+        <a:font script="Viet" typeface="Arial"/>
+        <a:font script="Uigh" typeface="Microsoft Uighur"/>
+        <a:font script="Geor" typeface="Sylfaen"/>
+        <a:font script="Armn" typeface="Arial"/>
+        <a:font script="Bugi" typeface="Leelawadee UI"/>
+        <a:font script="Bopo" typeface="Microsoft JhengHei"/>
+        <a:font script="Java" typeface="Javanese Text"/>
+        <a:font script="Lisu" typeface="Segoe UI"/>
+        <a:font script="Mymr" typeface="Myanmar Text"/>
+        <a:font script="Nkoo" typeface="Ebrima"/>
+        <a:font script="Olck" typeface="Nirmala UI"/>
+        <a:font script="Osma" typeface="Ebrima"/>
+        <a:font script="Phag" typeface="Phagspa"/>
+        <a:font script="Syrn" typeface="Estrangelo Edessa"/>
+        <a:font script="Syrj" typeface="Estrangelo Edessa"/>
+        <a:font script="Syre" typeface="Estrangelo Edessa"/>
+        <a:font script="Sora" typeface="Nirmala UI"/>
+        <a:font script="Tale" typeface="Microsoft Tai Le"/>
+        <a:font script="Talu" typeface="Microsoft New Tai Lue"/>
+        <a:font script="Tfng" typeface="Ebrima"/>
+      </a:minorFont>
+    </a:fontScheme>
+    <a:fmtScheme name="Office">
+      <a:fillStyleLst>
+        <a:solidFill>
+          <a:schemeClr val="phClr"/>
+        </a:solidFill>
+        <a:gradFill rotWithShape="1">
+          <a:gsLst>
+            <a:gs pos="0">
+              <a:schemeClr val="phClr">
+                <a:lumMod val="110000"/>
+                <a:satMod val="105000"/>
+                <a:tint val="67000"/>
+              </a:schemeClr>
+            </a:gs>
+            <a:gs pos="50000">
+              <a:schemeClr val="phClr">
+                <a:lumMod val="105000"/>
+                <a:satMod val="103000"/>
+                <a:tint val="73000"/>
+              </a:schemeClr>
+            </a:gs>
+            <a:gs pos="100000">
+              <a:schemeClr val="phClr">
+                <a:lumMod val="105000"/>
+                <a:satMod val="109000"/>
+                <a:tint val="81000"/>
+              </a:schemeClr>
+            </a:gs>
+          </a:gsLst>
+          <a:lin ang="5400000" scaled="0"/>
+        </a:gradFill>
+        <a:gradFill rotWithShape="1">
+          <a:gsLst>
+            <a:gs pos="0">
+              <a:schemeClr val="phClr">
+                <a:satMod val="103000"/>
+                <a:lumMod val="102000"/>
+                <a:tint val="94000"/>
+              </a:schemeClr>
+            </a:gs>
+            <a:gs pos="50000">
+              <a:schemeClr val="phClr">
+                <a:satMod val="110000"/>
+                <a:lumMod val="100000"/>
+                <a:shade val="100000"/>
+              </a:schemeClr>
+            </a:gs>
+            <a:gs pos="100000">
+              <a:schemeClr val="phClr">
+                <a:lumMod val="99000"/>
+                <a:satMod val="120000"/>
+                <a:shade val="78000"/>
+              </a:schemeClr>
+            </a:gs>
+          </a:gsLst>
+          <a:lin ang="5400000" scaled="0"/>
+        </a:gradFill>
+      </a:fillStyleLst>
+      <a:lnStyleLst>
+        <a:ln w="12700" cap="flat" cmpd="sng" algn="ctr">
+          <a:solidFill>
+            <a:schemeClr val="phClr"/>
+          </a:solidFill>
+          <a:prstDash val="solid"/>
+          <a:miter lim="800000"/>
+        </a:ln>
+        <a:ln w="19050" cap="flat" cmpd="sng" algn="ctr">
+          <a:solidFill>
+            <a:schemeClr val="phClr"/>
+          </a:solidFill>
+          <a:prstDash val="solid"/>
+          <a:miter lim="800000"/>
+        </a:ln>
+        <a:ln w="25400" cap="flat" cmpd="sng" algn="ctr">
+          <a:solidFill>
+            <a:schemeClr val="phClr"/>
+          </a:solidFill>
+          <a:prstDash val="solid"/>
+          <a:miter lim="800000"/>
+        </a:ln>
+      </a:lnStyleLst>
+      <a:effectStyleLst>
+        <a:effectStyle>
+          <a:effectLst/>
+        </a:effectStyle>
+        <a:effectStyle>
+          <a:effectLst/>
+        </a:effectStyle>
+        <a:effectStyle>
+          <a:effectLst>
+            <a:outerShdw blurRad="57150" dist="19050" dir="5400000" algn="ctr" rotWithShape="0">
+              <a:srgbClr val="000000">
+                <a:alpha val="63000"/>
+              </a:srgbClr>
+            </a:outerShdw>
+          </a:effectLst>
+        </a:effectStyle>
+      </a:effectStyleLst>
+      <a:bgFillStyleLst>
+        <a:solidFill>
+          <a:schemeClr val="phClr"/>
+        </a:solidFill>
+        <a:solidFill>
+          <a:schemeClr val="phClr">
+            <a:tint val="95000"/>
+            <a:satMod val="170000"/>
+          </a:schemeClr>
+        </a:solidFill>
+        <a:gradFill rotWithShape="1">
+          <a:gsLst>
+            <a:gs pos="0">
+              <a:schemeClr val="phClr">
+                <a:tint val="93000"/>
+                <a:satMod val="150000"/>
+                <a:shade val="98000"/>
+                <a:lumMod val="102000"/>
+              </a:schemeClr>
+            </a:gs>
+            <a:gs pos="50000">
+              <a:schemeClr val="phClr">
+                <a:tint val="98000"/>
+                <a:satMod val="130000"/>
+                <a:shade val="90000"/>
+                <a:lumMod val="103000"/>
+              </a:schemeClr>
+            </a:gs>
+            <a:gs pos="100000">
+              <a:schemeClr val="phClr">
+                <a:shade val="63000"/>
+                <a:satMod val="120000"/>
+              </a:schemeClr>
+            </a:gs>
+          </a:gsLst>
+          <a:lin ang="5400000" scaled="0"/>
+        </a:gradFill>
+      </a:bgFillStyleLst>
+    </a:fmtScheme>
+  </a:themeElements>
+  <a:objectDefaults>
+    <a:lnDef>
+      <a:spPr/>
+      <a:bodyPr/>
+      <a:lstStyle/>
+      <a:style>
+        <a:lnRef idx="2">
+          <a:schemeClr val="accent1"/>
+        </a:lnRef>
+        <a:fillRef idx="0">
+          <a:schemeClr val="accent1"/>
+        </a:fillRef>
+        <a:effectRef idx="1">
+          <a:schemeClr val="accent1"/>
+        </a:effectRef>
+        <a:fontRef idx="minor">
+          <a:schemeClr val="tx1"/>
+        </a:fontRef>
+      </a:style>
+    </a:lnDef>
+  </a:objectDefaults>
+  <a:extraClrSchemeLst/>
+  <a:extLst>
+    <a:ext uri="{05A4C25C-085E-4340-85A3-A5531E510DB2}">
+      <thm15:themeFamily xmlns:thm15="http://schemas.microsoft.com/office/thememl/2012/main" name="Office Theme" id="{2E142A2C-CD16-42D6-873A-C26D2A0506FA}" vid="{1BDDFF52-6CD6-40A5-AB3C-68EB2F1E4D0A}"/>
+    </a:ext>
+  </a:extLst>
+</a:theme>
 </file>
</xml_diff>